<commit_message>
clarification on network analysis methods
</commit_message>
<xml_diff>
--- a/slides/2_DCcircuits.pptx
+++ b/slides/2_DCcircuits.pptx
@@ -5,7 +5,7 @@
     <p:sldMasterId id="2147483648" r:id="rId1"/>
   </p:sldMasterIdLst>
   <p:notesMasterIdLst>
-    <p:notesMasterId r:id="rId33"/>
+    <p:notesMasterId r:id="rId34"/>
   </p:notesMasterIdLst>
   <p:sldIdLst>
     <p:sldId id="257" r:id="rId2"/>
@@ -35,10 +35,11 @@
     <p:sldId id="295" r:id="rId26"/>
     <p:sldId id="294" r:id="rId27"/>
     <p:sldId id="293" r:id="rId28"/>
-    <p:sldId id="292" r:id="rId29"/>
-    <p:sldId id="290" r:id="rId30"/>
-    <p:sldId id="291" r:id="rId31"/>
-    <p:sldId id="296" r:id="rId32"/>
+    <p:sldId id="298" r:id="rId29"/>
+    <p:sldId id="292" r:id="rId30"/>
+    <p:sldId id="290" r:id="rId31"/>
+    <p:sldId id="291" r:id="rId32"/>
+    <p:sldId id="296" r:id="rId33"/>
   </p:sldIdLst>
   <p:sldSz cx="12192000" cy="6858000"/>
   <p:notesSz cx="6858000" cy="9144000"/>
@@ -227,7 +228,7 @@
           <a:p>
             <a:fld id="{50F0DBE5-119B-9546-A717-70798062973B}" type="datetimeFigureOut">
               <a:rPr lang="de-DE" smtClean="0"/>
-              <a:t>06.11.25</a:t>
+              <a:t>15.11.25</a:t>
             </a:fld>
             <a:endParaRPr lang="de-DE"/>
           </a:p>
@@ -641,7 +642,7 @@
           <a:p>
             <a:fld id="{CE5B6352-3465-4344-964A-B25153893676}" type="datetime1">
               <a:rPr lang="de-DE" smtClean="0"/>
-              <a:t>06.11.25</a:t>
+              <a:t>15.11.25</a:t>
             </a:fld>
             <a:endParaRPr lang="de-DE"/>
           </a:p>
@@ -839,7 +840,7 @@
           <a:p>
             <a:fld id="{680476C1-F079-0F40-9C5B-039EA12ABDAA}" type="datetime1">
               <a:rPr lang="de-DE" smtClean="0"/>
-              <a:t>06.11.25</a:t>
+              <a:t>15.11.25</a:t>
             </a:fld>
             <a:endParaRPr lang="de-DE"/>
           </a:p>
@@ -1047,7 +1048,7 @@
           <a:p>
             <a:fld id="{95A166F0-C736-5846-BD29-206B3FE0CE89}" type="datetime1">
               <a:rPr lang="de-DE" smtClean="0"/>
-              <a:t>06.11.25</a:t>
+              <a:t>15.11.25</a:t>
             </a:fld>
             <a:endParaRPr lang="de-DE"/>
           </a:p>
@@ -1245,7 +1246,7 @@
           <a:p>
             <a:fld id="{C501BE91-62CD-C14F-A910-7294FC82D4A0}" type="datetime1">
               <a:rPr lang="de-DE" smtClean="0"/>
-              <a:t>06.11.25</a:t>
+              <a:t>15.11.25</a:t>
             </a:fld>
             <a:endParaRPr lang="de-DE"/>
           </a:p>
@@ -1520,7 +1521,7 @@
           <a:p>
             <a:fld id="{BF974C23-8003-8246-BE47-B5ECC9F69FCF}" type="datetime1">
               <a:rPr lang="de-DE" smtClean="0"/>
-              <a:t>06.11.25</a:t>
+              <a:t>15.11.25</a:t>
             </a:fld>
             <a:endParaRPr lang="de-DE"/>
           </a:p>
@@ -1785,7 +1786,7 @@
           <a:p>
             <a:fld id="{9399C134-D3BA-F044-A1BA-5D8F00C16B33}" type="datetime1">
               <a:rPr lang="de-DE" smtClean="0"/>
-              <a:t>06.11.25</a:t>
+              <a:t>15.11.25</a:t>
             </a:fld>
             <a:endParaRPr lang="de-DE"/>
           </a:p>
@@ -2197,7 +2198,7 @@
           <a:p>
             <a:fld id="{CAA0E14A-B13F-B84D-BA0A-4382E133E05F}" type="datetime1">
               <a:rPr lang="de-DE" smtClean="0"/>
-              <a:t>06.11.25</a:t>
+              <a:t>15.11.25</a:t>
             </a:fld>
             <a:endParaRPr lang="de-DE"/>
           </a:p>
@@ -2338,7 +2339,7 @@
           <a:p>
             <a:fld id="{82499081-64A1-E641-A060-B3FE5E7414AE}" type="datetime1">
               <a:rPr lang="de-DE" smtClean="0"/>
-              <a:t>06.11.25</a:t>
+              <a:t>15.11.25</a:t>
             </a:fld>
             <a:endParaRPr lang="de-DE"/>
           </a:p>
@@ -2451,7 +2452,7 @@
           <a:p>
             <a:fld id="{72507737-E8BF-5348-A8D5-F635D39F9B4A}" type="datetime1">
               <a:rPr lang="de-DE" smtClean="0"/>
-              <a:t>06.11.25</a:t>
+              <a:t>15.11.25</a:t>
             </a:fld>
             <a:endParaRPr lang="de-DE"/>
           </a:p>
@@ -2762,7 +2763,7 @@
           <a:p>
             <a:fld id="{E5AF2D44-8DB2-1E42-B969-A879F4E80DE2}" type="datetime1">
               <a:rPr lang="de-DE" smtClean="0"/>
-              <a:t>06.11.25</a:t>
+              <a:t>15.11.25</a:t>
             </a:fld>
             <a:endParaRPr lang="de-DE"/>
           </a:p>
@@ -3050,7 +3051,7 @@
           <a:p>
             <a:fld id="{BDCC8AD7-B1B1-5742-9D45-5FF116011C65}" type="datetime1">
               <a:rPr lang="de-DE" smtClean="0"/>
-              <a:t>06.11.25</a:t>
+              <a:t>15.11.25</a:t>
             </a:fld>
             <a:endParaRPr lang="de-DE"/>
           </a:p>
@@ -3291,7 +3292,7 @@
           <a:p>
             <a:fld id="{108D9C44-3672-2C4D-8D64-277C579E81B1}" type="datetime1">
               <a:rPr lang="de-DE" smtClean="0"/>
-              <a:t>06.11.25</a:t>
+              <a:t>15.11.25</a:t>
             </a:fld>
             <a:endParaRPr lang="de-DE"/>
           </a:p>
@@ -14575,14 +14576,6 @@
           <a:p>
             <a:r>
               <a:rPr lang="de-DE" dirty="0" err="1"/>
-              <a:t>Example</a:t>
-            </a:r>
-            <a:r>
-              <a:rPr lang="de-DE" dirty="0"/>
-              <a:t>: </a:t>
-            </a:r>
-            <a:r>
-              <a:rPr lang="de-DE" dirty="0" err="1"/>
               <a:t>Representation</a:t>
             </a:r>
             <a:endParaRPr lang="de-DE" dirty="0"/>
@@ -16290,14 +16283,6 @@
           <a:bodyPr/>
           <a:lstStyle/>
           <a:p>
-            <a:r>
-              <a:rPr lang="de-DE" dirty="0" err="1"/>
-              <a:t>Example</a:t>
-            </a:r>
-            <a:r>
-              <a:rPr lang="de-DE" dirty="0"/>
-              <a:t>: </a:t>
-            </a:r>
             <a:r>
               <a:rPr lang="de-DE" dirty="0" err="1"/>
               <a:t>Formulation</a:t>
@@ -17117,13 +17102,14 @@
           <a:lstStyle/>
           <a:p>
             <a:r>
+              <a:rPr lang="de-DE" dirty="0"/>
+              <a:t>Approach 1: Use </a:t>
+            </a:r>
+            <a:r>
               <a:rPr lang="de-DE" dirty="0" err="1"/>
-              <a:t>Example</a:t>
-            </a:r>
-            <a:r>
-              <a:rPr lang="de-DE" dirty="0"/>
-              <a:t>: Mesh Analysis</a:t>
-            </a:r>
+              <a:t>Meshes</a:t>
+            </a:r>
+            <a:endParaRPr lang="de-DE" dirty="0"/>
           </a:p>
         </p:txBody>
       </p:sp>
@@ -17152,10 +17138,6 @@
               <a:buNone/>
             </a:pPr>
             <a:r>
-              <a:rPr lang="de-DE" dirty="0"/>
-              <a:t>pick </a:t>
-            </a:r>
-            <a:r>
               <a:rPr lang="de-DE" dirty="0" err="1"/>
               <a:t>meshes</a:t>
             </a:r>
@@ -17252,15 +17234,7 @@
             </a:r>
             <a:r>
               <a:rPr lang="de-DE" dirty="0"/>
-              <a:t> loop/</a:t>
-            </a:r>
-            <a:r>
-              <a:rPr lang="de-DE" dirty="0" err="1"/>
-              <a:t>mesh</a:t>
-            </a:r>
-            <a:r>
-              <a:rPr lang="de-DE" dirty="0"/>
-              <a:t> </a:t>
+              <a:t> loop </a:t>
             </a:r>
             <a:r>
               <a:rPr lang="de-DE" dirty="0" err="1"/>
@@ -18008,6 +17982,66 @@
           </a:p>
         </p:txBody>
       </p:sp>
+      <p:sp>
+        <p:nvSpPr>
+          <p:cNvPr id="5" name="Textfeld 4">
+            <a:extLst>
+              <a:ext uri="{FF2B5EF4-FFF2-40B4-BE49-F238E27FC236}">
+                <a16:creationId xmlns:a16="http://schemas.microsoft.com/office/drawing/2014/main" id="{D338373B-3F11-E2F2-EA1F-D79AC6A2E01F}"/>
+              </a:ext>
+            </a:extLst>
+          </p:cNvPr>
+          <p:cNvSpPr txBox="1"/>
+          <p:nvPr/>
+        </p:nvSpPr>
+        <p:spPr>
+          <a:xfrm>
+            <a:off x="8431355" y="38906"/>
+            <a:ext cx="3760645" cy="369332"/>
+          </a:xfrm>
+          <a:prstGeom prst="rect">
+            <a:avLst/>
+          </a:prstGeom>
+          <a:noFill/>
+        </p:spPr>
+        <p:txBody>
+          <a:bodyPr wrap="none" rtlCol="0">
+            <a:spAutoFit/>
+          </a:bodyPr>
+          <a:lstStyle/>
+          <a:p>
+            <a:r>
+              <a:rPr lang="de-DE" dirty="0" err="1"/>
+              <a:t>one</a:t>
+            </a:r>
+            <a:r>
+              <a:rPr lang="de-DE" dirty="0"/>
+              <a:t> </a:t>
+            </a:r>
+            <a:r>
+              <a:rPr lang="de-DE" dirty="0" err="1"/>
+              <a:t>more</a:t>
+            </a:r>
+            <a:r>
+              <a:rPr lang="de-DE" dirty="0"/>
+              <a:t> alternative: </a:t>
+            </a:r>
+            <a:r>
+              <a:rPr lang="de-DE" dirty="0" err="1"/>
+              <a:t>mesh</a:t>
+            </a:r>
+            <a:r>
+              <a:rPr lang="de-DE" dirty="0"/>
+              <a:t> </a:t>
+            </a:r>
+            <a:r>
+              <a:rPr lang="de-DE" dirty="0" err="1"/>
+              <a:t>analysis</a:t>
+            </a:r>
+            <a:endParaRPr lang="de-DE" dirty="0"/>
+          </a:p>
+        </p:txBody>
+      </p:sp>
     </p:spTree>
     <p:extLst>
       <p:ext uri="{BB962C8B-B14F-4D97-AF65-F5344CB8AC3E}">
@@ -18062,12 +18096,8 @@
           <a:lstStyle/>
           <a:p>
             <a:r>
-              <a:rPr lang="de-DE" dirty="0" err="1"/>
-              <a:t>Example</a:t>
-            </a:r>
-            <a:r>
               <a:rPr lang="de-DE" dirty="0"/>
-              <a:t>: Method </a:t>
+              <a:t>Approach 2: Method </a:t>
             </a:r>
             <a:r>
               <a:rPr lang="de-DE" dirty="0" err="1"/>
@@ -19403,12 +19433,8 @@
           <a:lstStyle/>
           <a:p>
             <a:r>
-              <a:rPr lang="de-DE" dirty="0" err="1"/>
-              <a:t>Example</a:t>
-            </a:r>
-            <a:r>
               <a:rPr lang="de-DE" dirty="0"/>
-              <a:t>: System </a:t>
+              <a:t>System </a:t>
             </a:r>
             <a:r>
               <a:rPr lang="de-DE" dirty="0" err="1"/>
@@ -21040,6 +21066,1570 @@
           <a:chExt cx="0" cy="0"/>
         </a:xfrm>
       </p:grpSpPr>
+      <mc:AlternateContent xmlns:mc="http://schemas.openxmlformats.org/markup-compatibility/2006">
+        <mc:Choice xmlns:a14="http://schemas.microsoft.com/office/drawing/2010/main" Requires="a14">
+          <p:sp>
+            <p:nvSpPr>
+              <p:cNvPr id="4" name="Inhaltsplatzhalter 3">
+                <a:extLst>
+                  <a:ext uri="{FF2B5EF4-FFF2-40B4-BE49-F238E27FC236}">
+                    <a16:creationId xmlns:a16="http://schemas.microsoft.com/office/drawing/2014/main" id="{6085456F-BCA5-FD69-44B0-E5D37499EC5D}"/>
+                  </a:ext>
+                </a:extLst>
+              </p:cNvPr>
+              <p:cNvSpPr>
+                <a:spLocks noGrp="1"/>
+              </p:cNvSpPr>
+              <p:nvPr>
+                <p:ph idx="1"/>
+              </p:nvPr>
+            </p:nvSpPr>
+            <p:spPr>
+              <a:xfrm>
+                <a:off x="382210" y="1690688"/>
+                <a:ext cx="8706301" cy="5030787"/>
+              </a:xfrm>
+            </p:spPr>
+            <p:txBody>
+              <a:bodyPr>
+                <a:normAutofit lnSpcReduction="10000"/>
+              </a:bodyPr>
+              <a:lstStyle/>
+              <a:p>
+                <a:pPr marL="0" indent="0">
+                  <a:buNone/>
+                </a:pPr>
+                <a:r>
+                  <a:rPr lang="de-DE" sz="2400" dirty="0" err="1"/>
+                  <a:t>sometimes</a:t>
+                </a:r>
+                <a:r>
+                  <a:rPr lang="de-DE" sz="2400" dirty="0"/>
+                  <a:t> simpler </a:t>
+                </a:r>
+                <a:r>
+                  <a:rPr lang="de-DE" sz="2400" dirty="0" err="1"/>
+                  <a:t>approach</a:t>
+                </a:r>
+                <a:r>
+                  <a:rPr lang="de-DE" sz="2400" dirty="0"/>
+                  <a:t>:</a:t>
+                </a:r>
+              </a:p>
+              <a:p>
+                <a:pPr marL="0" indent="0">
+                  <a:buNone/>
+                </a:pPr>
+                <a:endParaRPr lang="de-DE" sz="2400" dirty="0"/>
+              </a:p>
+              <a:p>
+                <a:r>
+                  <a:rPr lang="de-DE" sz="2400" dirty="0" err="1"/>
+                  <a:t>select</a:t>
+                </a:r>
+                <a:r>
+                  <a:rPr lang="de-DE" sz="2400" dirty="0"/>
+                  <a:t> </a:t>
+                </a:r>
+                <a:r>
+                  <a:rPr lang="de-DE" sz="2400" dirty="0" err="1"/>
+                  <a:t>one</a:t>
+                </a:r>
+                <a:r>
+                  <a:rPr lang="de-DE" sz="2400" dirty="0"/>
+                  <a:t> </a:t>
+                </a:r>
+                <a:r>
+                  <a:rPr lang="de-DE" sz="2400" dirty="0" err="1"/>
+                  <a:t>node</a:t>
+                </a:r>
+                <a:r>
+                  <a:rPr lang="de-DE" sz="2400" dirty="0"/>
+                  <a:t> </a:t>
+                </a:r>
+                <a:r>
+                  <a:rPr lang="de-DE" sz="2400" dirty="0" err="1"/>
+                  <a:t>as</a:t>
+                </a:r>
+                <a:r>
+                  <a:rPr lang="de-DE" sz="2400" dirty="0"/>
+                  <a:t> </a:t>
+                </a:r>
+                <a:r>
+                  <a:rPr lang="de-DE" sz="2400" dirty="0" err="1"/>
+                  <a:t>reference</a:t>
+                </a:r>
+                <a:r>
+                  <a:rPr lang="de-DE" sz="2400" dirty="0"/>
+                  <a:t> </a:t>
+                </a:r>
+                <a:r>
+                  <a:rPr lang="de-DE" sz="2400" dirty="0" err="1"/>
+                  <a:t>node</a:t>
+                </a:r>
+                <a:r>
+                  <a:rPr lang="de-DE" sz="2400" dirty="0"/>
+                  <a:t> </a:t>
+                </a:r>
+                <a:r>
+                  <a:rPr lang="de-DE" sz="2400" dirty="0" err="1"/>
+                  <a:t>with</a:t>
+                </a:r>
+                <a:r>
+                  <a:rPr lang="de-DE" sz="2400" dirty="0"/>
+                  <a:t> an </a:t>
+                </a:r>
+                <a:r>
+                  <a:rPr lang="de-DE" sz="2400" dirty="0" err="1"/>
+                  <a:t>arbitrary</a:t>
+                </a:r>
+                <a:r>
+                  <a:rPr lang="de-DE" sz="2400" dirty="0"/>
+                  <a:t> potential (</a:t>
+                </a:r>
+                <a:r>
+                  <a:rPr lang="de-DE" sz="2400" dirty="0" err="1"/>
+                  <a:t>typically</a:t>
+                </a:r>
+                <a:r>
+                  <a:rPr lang="de-DE" sz="2400" dirty="0"/>
+                  <a:t> </a:t>
+                </a:r>
+                <a:r>
+                  <a:rPr lang="de-DE" sz="2400" dirty="0" err="1"/>
+                  <a:t>ground</a:t>
+                </a:r>
+                <a:r>
+                  <a:rPr lang="de-DE" sz="2400" dirty="0"/>
+                  <a:t>, i.e., </a:t>
+                </a:r>
+                <a14:m>
+                  <m:oMath xmlns:m="http://schemas.openxmlformats.org/officeDocument/2006/math">
+                    <m:r>
+                      <a:rPr lang="de-DE" sz="2400" b="0" i="1" smtClean="0">
+                        <a:latin typeface="Cambria Math" panose="02040503050406030204" pitchFamily="18" charset="0"/>
+                      </a:rPr>
+                      <m:t>𝑉</m:t>
+                    </m:r>
+                    <m:r>
+                      <a:rPr lang="de-DE" sz="2400" b="0" i="1" smtClean="0">
+                        <a:latin typeface="Cambria Math" panose="02040503050406030204" pitchFamily="18" charset="0"/>
+                      </a:rPr>
+                      <m:t>=0</m:t>
+                    </m:r>
+                  </m:oMath>
+                </a14:m>
+                <a:r>
+                  <a:rPr lang="de-DE" sz="2400" dirty="0"/>
+                  <a:t>)</a:t>
+                </a:r>
+              </a:p>
+              <a:p>
+                <a:pPr marL="0" indent="0">
+                  <a:buNone/>
+                </a:pPr>
+                <a:endParaRPr lang="de-DE" sz="2400" dirty="0"/>
+              </a:p>
+              <a:p>
+                <a:r>
+                  <a:rPr lang="de-DE" sz="2400" dirty="0" err="1"/>
+                  <a:t>apply</a:t>
+                </a:r>
+                <a:r>
+                  <a:rPr lang="de-DE" sz="2400" dirty="0"/>
+                  <a:t> KCL </a:t>
+                </a:r>
+                <a:r>
+                  <a:rPr lang="de-DE" sz="2400" dirty="0" err="1"/>
+                  <a:t>to</a:t>
+                </a:r>
+                <a:r>
+                  <a:rPr lang="de-DE" sz="2400" dirty="0"/>
+                  <a:t> </a:t>
+                </a:r>
+                <a14:m>
+                  <m:oMath xmlns:m="http://schemas.openxmlformats.org/officeDocument/2006/math">
+                    <m:r>
+                      <a:rPr lang="de-DE" sz="2400" i="1">
+                        <a:latin typeface="Cambria Math" panose="02040503050406030204" pitchFamily="18" charset="0"/>
+                      </a:rPr>
+                      <m:t>𝑛</m:t>
+                    </m:r>
+                    <m:r>
+                      <a:rPr lang="de-DE" sz="2400" i="1">
+                        <a:latin typeface="Cambria Math" panose="02040503050406030204" pitchFamily="18" charset="0"/>
+                      </a:rPr>
+                      <m:t>−1</m:t>
+                    </m:r>
+                  </m:oMath>
+                </a14:m>
+                <a:r>
+                  <a:rPr lang="de-DE" sz="2400" dirty="0"/>
+                  <a:t> non-</a:t>
+                </a:r>
+                <a:r>
+                  <a:rPr lang="de-DE" sz="2400" dirty="0" err="1"/>
+                  <a:t>reference</a:t>
+                </a:r>
+                <a:r>
+                  <a:rPr lang="de-DE" sz="2400" dirty="0"/>
+                  <a:t> </a:t>
+                </a:r>
+                <a:r>
+                  <a:rPr lang="de-DE" sz="2400" dirty="0" err="1"/>
+                  <a:t>nodes</a:t>
+                </a:r>
+                <a:endParaRPr lang="de-DE" sz="2400" dirty="0"/>
+              </a:p>
+              <a:p>
+                <a:pPr marL="0" indent="0">
+                  <a:buNone/>
+                </a:pPr>
+                <a:endParaRPr lang="de-DE" sz="2400" dirty="0"/>
+              </a:p>
+              <a:p>
+                <a:pPr marL="0" indent="0">
+                  <a:buNone/>
+                </a:pPr>
+                <a:endParaRPr lang="de-DE" sz="2400" dirty="0"/>
+              </a:p>
+              <a:p>
+                <a:r>
+                  <a:rPr lang="de-DE" sz="2400" dirty="0" err="1"/>
+                  <a:t>apply</a:t>
+                </a:r>
+                <a:r>
+                  <a:rPr lang="de-DE" sz="2400" dirty="0"/>
+                  <a:t> </a:t>
+                </a:r>
+                <a:r>
+                  <a:rPr lang="de-DE" sz="2400" dirty="0" err="1"/>
+                  <a:t>Ohm‘s</a:t>
+                </a:r>
+                <a:r>
+                  <a:rPr lang="de-DE" sz="2400" dirty="0"/>
+                  <a:t> </a:t>
+                </a:r>
+                <a:r>
+                  <a:rPr lang="de-DE" sz="2400" dirty="0" err="1"/>
+                  <a:t>law</a:t>
+                </a:r>
+                <a:r>
+                  <a:rPr lang="de-DE" sz="2400" dirty="0"/>
+                  <a:t> </a:t>
+                </a:r>
+                <a:r>
+                  <a:rPr lang="de-DE" sz="2400" dirty="0" err="1"/>
+                  <a:t>to</a:t>
+                </a:r>
+                <a:r>
+                  <a:rPr lang="de-DE" sz="2400" dirty="0"/>
+                  <a:t> express </a:t>
+                </a:r>
+                <a:r>
+                  <a:rPr lang="de-DE" sz="2400" dirty="0" err="1"/>
+                  <a:t>currents</a:t>
+                </a:r>
+                <a:r>
+                  <a:rPr lang="de-DE" sz="2400" dirty="0"/>
+                  <a:t> in </a:t>
+                </a:r>
+                <a:r>
+                  <a:rPr lang="de-DE" sz="2400" dirty="0" err="1"/>
+                  <a:t>terms</a:t>
+                </a:r>
+                <a:r>
+                  <a:rPr lang="de-DE" sz="2400" dirty="0"/>
+                  <a:t> </a:t>
+                </a:r>
+                <a:r>
+                  <a:rPr lang="de-DE" sz="2400" dirty="0" err="1"/>
+                  <a:t>of</a:t>
+                </a:r>
+                <a:r>
+                  <a:rPr lang="de-DE" sz="2400" dirty="0"/>
+                  <a:t> </a:t>
+                </a:r>
+                <a:r>
+                  <a:rPr lang="de-DE" sz="2400" dirty="0" err="1"/>
+                  <a:t>node</a:t>
+                </a:r>
+                <a:r>
+                  <a:rPr lang="de-DE" sz="2400" dirty="0"/>
+                  <a:t> </a:t>
+                </a:r>
+                <a:r>
+                  <a:rPr lang="de-DE" sz="2400" dirty="0" err="1"/>
+                  <a:t>voltages</a:t>
+                </a:r>
+                <a:r>
+                  <a:rPr lang="de-DE" sz="2400" dirty="0"/>
+                  <a:t>:</a:t>
+                </a:r>
+              </a:p>
+              <a:p>
+                <a:pPr marL="0" indent="0">
+                  <a:buNone/>
+                </a:pPr>
+                <a:endParaRPr lang="de-DE" sz="2400" dirty="0"/>
+              </a:p>
+              <a:p>
+                <a:pPr marL="0" indent="0">
+                  <a:buNone/>
+                </a:pPr>
+                <a:endParaRPr lang="de-DE" sz="2400" dirty="0"/>
+              </a:p>
+              <a:p>
+                <a:r>
+                  <a:rPr lang="de-DE" sz="2400" dirty="0" err="1"/>
+                  <a:t>substitute</a:t>
+                </a:r>
+                <a:r>
+                  <a:rPr lang="de-DE" sz="2400" dirty="0"/>
+                  <a:t> and </a:t>
+                </a:r>
+                <a:r>
+                  <a:rPr lang="de-DE" sz="2400" dirty="0" err="1"/>
+                  <a:t>solve</a:t>
+                </a:r>
+                <a:endParaRPr lang="de-DE" sz="2400" dirty="0"/>
+              </a:p>
+            </p:txBody>
+          </p:sp>
+        </mc:Choice>
+        <mc:Fallback>
+          <p:sp>
+            <p:nvSpPr>
+              <p:cNvPr id="4" name="Inhaltsplatzhalter 3">
+                <a:extLst>
+                  <a:ext uri="{FF2B5EF4-FFF2-40B4-BE49-F238E27FC236}">
+                    <a16:creationId xmlns:a16="http://schemas.microsoft.com/office/drawing/2014/main" id="{6085456F-BCA5-FD69-44B0-E5D37499EC5D}"/>
+                  </a:ext>
+                </a:extLst>
+              </p:cNvPr>
+              <p:cNvSpPr>
+                <a:spLocks noGrp="1" noRot="1" noChangeAspect="1" noMove="1" noResize="1" noEditPoints="1" noAdjustHandles="1" noChangeArrowheads="1" noChangeShapeType="1" noTextEdit="1"/>
+              </p:cNvSpPr>
+              <p:nvPr>
+                <p:ph idx="1"/>
+              </p:nvPr>
+            </p:nvSpPr>
+            <p:spPr>
+              <a:xfrm>
+                <a:off x="382210" y="1690688"/>
+                <a:ext cx="8706301" cy="5030787"/>
+              </a:xfrm>
+              <a:blipFill>
+                <a:blip r:embed="rId2"/>
+                <a:stretch>
+                  <a:fillRect l="-1166" t="-2010"/>
+                </a:stretch>
+              </a:blipFill>
+            </p:spPr>
+            <p:txBody>
+              <a:bodyPr/>
+              <a:lstStyle/>
+              <a:p>
+                <a:r>
+                  <a:rPr lang="de-DE">
+                    <a:noFill/>
+                  </a:rPr>
+                  <a:t> </a:t>
+                </a:r>
+              </a:p>
+            </p:txBody>
+          </p:sp>
+        </mc:Fallback>
+      </mc:AlternateContent>
+      <mc:AlternateContent xmlns:mc="http://schemas.openxmlformats.org/markup-compatibility/2006">
+        <mc:Choice xmlns:a14="http://schemas.microsoft.com/office/drawing/2010/main" Requires="a14">
+          <p:sp>
+            <p:nvSpPr>
+              <p:cNvPr id="27" name="Textfeld 26">
+                <a:extLst>
+                  <a:ext uri="{FF2B5EF4-FFF2-40B4-BE49-F238E27FC236}">
+                    <a16:creationId xmlns:a16="http://schemas.microsoft.com/office/drawing/2014/main" id="{F84AF832-11DD-714E-68B6-F1EE3DCAFE47}"/>
+                  </a:ext>
+                </a:extLst>
+              </p:cNvPr>
+              <p:cNvSpPr txBox="1"/>
+              <p:nvPr/>
+            </p:nvSpPr>
+            <p:spPr>
+              <a:xfrm>
+                <a:off x="838200" y="4176001"/>
+                <a:ext cx="5935343" cy="369332"/>
+              </a:xfrm>
+              <a:prstGeom prst="rect">
+                <a:avLst/>
+              </a:prstGeom>
+              <a:noFill/>
+              <a:ln>
+                <a:solidFill>
+                  <a:schemeClr val="tx1"/>
+                </a:solidFill>
+              </a:ln>
+            </p:spPr>
+            <p:txBody>
+              <a:bodyPr wrap="none" rtlCol="0">
+                <a:spAutoFit/>
+              </a:bodyPr>
+              <a:lstStyle/>
+              <a:p>
+                <a:r>
+                  <a:rPr lang="de-DE" dirty="0"/>
+                  <a:t>here:	node1: </a:t>
+                </a:r>
+                <a14:m>
+                  <m:oMath xmlns:m="http://schemas.openxmlformats.org/officeDocument/2006/math">
+                    <m:sSub>
+                      <m:sSubPr>
+                        <m:ctrlPr>
+                          <a:rPr lang="de-DE" i="1" smtClean="0">
+                            <a:latin typeface="Cambria Math" panose="02040503050406030204" pitchFamily="18" charset="0"/>
+                          </a:rPr>
+                        </m:ctrlPr>
+                      </m:sSubPr>
+                      <m:e>
+                        <m:r>
+                          <a:rPr lang="de-DE" b="0" i="1" smtClean="0">
+                            <a:latin typeface="Cambria Math" panose="02040503050406030204" pitchFamily="18" charset="0"/>
+                          </a:rPr>
+                          <m:t>𝐼</m:t>
+                        </m:r>
+                      </m:e>
+                      <m:sub>
+                        <m:r>
+                          <a:rPr lang="de-DE" b="0" i="1" smtClean="0">
+                            <a:latin typeface="Cambria Math" panose="02040503050406030204" pitchFamily="18" charset="0"/>
+                          </a:rPr>
+                          <m:t>1</m:t>
+                        </m:r>
+                      </m:sub>
+                    </m:sSub>
+                    <m:r>
+                      <a:rPr lang="de-DE" b="0" i="1" smtClean="0">
+                        <a:latin typeface="Cambria Math" panose="02040503050406030204" pitchFamily="18" charset="0"/>
+                      </a:rPr>
+                      <m:t>=</m:t>
+                    </m:r>
+                    <m:sSub>
+                      <m:sSubPr>
+                        <m:ctrlPr>
+                          <a:rPr lang="de-DE" b="0" i="1" smtClean="0">
+                            <a:latin typeface="Cambria Math" panose="02040503050406030204" pitchFamily="18" charset="0"/>
+                          </a:rPr>
+                        </m:ctrlPr>
+                      </m:sSubPr>
+                      <m:e>
+                        <m:r>
+                          <a:rPr lang="de-DE" b="0" i="1" smtClean="0">
+                            <a:latin typeface="Cambria Math" panose="02040503050406030204" pitchFamily="18" charset="0"/>
+                          </a:rPr>
+                          <m:t>𝐼</m:t>
+                        </m:r>
+                      </m:e>
+                      <m:sub>
+                        <m:r>
+                          <a:rPr lang="de-DE" b="0" i="1" smtClean="0">
+                            <a:latin typeface="Cambria Math" panose="02040503050406030204" pitchFamily="18" charset="0"/>
+                          </a:rPr>
+                          <m:t>2</m:t>
+                        </m:r>
+                      </m:sub>
+                    </m:sSub>
+                    <m:r>
+                      <a:rPr lang="de-DE" b="0" i="1" smtClean="0">
+                        <a:latin typeface="Cambria Math" panose="02040503050406030204" pitchFamily="18" charset="0"/>
+                      </a:rPr>
+                      <m:t>+</m:t>
+                    </m:r>
+                    <m:sSub>
+                      <m:sSubPr>
+                        <m:ctrlPr>
+                          <a:rPr lang="de-DE" b="0" i="1" smtClean="0">
+                            <a:latin typeface="Cambria Math" panose="02040503050406030204" pitchFamily="18" charset="0"/>
+                          </a:rPr>
+                        </m:ctrlPr>
+                      </m:sSubPr>
+                      <m:e>
+                        <m:r>
+                          <a:rPr lang="de-DE" b="0" i="1" smtClean="0">
+                            <a:latin typeface="Cambria Math" panose="02040503050406030204" pitchFamily="18" charset="0"/>
+                          </a:rPr>
+                          <m:t>𝑖</m:t>
+                        </m:r>
+                      </m:e>
+                      <m:sub>
+                        <m:r>
+                          <a:rPr lang="de-DE" b="0" i="1" smtClean="0">
+                            <a:latin typeface="Cambria Math" panose="02040503050406030204" pitchFamily="18" charset="0"/>
+                          </a:rPr>
+                          <m:t>1</m:t>
+                        </m:r>
+                      </m:sub>
+                    </m:sSub>
+                    <m:r>
+                      <a:rPr lang="de-DE" b="0" i="1" smtClean="0">
+                        <a:latin typeface="Cambria Math" panose="02040503050406030204" pitchFamily="18" charset="0"/>
+                      </a:rPr>
+                      <m:t>+</m:t>
+                    </m:r>
+                    <m:sSub>
+                      <m:sSubPr>
+                        <m:ctrlPr>
+                          <a:rPr lang="de-DE" b="0" i="1" smtClean="0">
+                            <a:latin typeface="Cambria Math" panose="02040503050406030204" pitchFamily="18" charset="0"/>
+                          </a:rPr>
+                        </m:ctrlPr>
+                      </m:sSubPr>
+                      <m:e>
+                        <m:r>
+                          <a:rPr lang="de-DE" b="0" i="1" smtClean="0">
+                            <a:latin typeface="Cambria Math" panose="02040503050406030204" pitchFamily="18" charset="0"/>
+                          </a:rPr>
+                          <m:t>𝑖</m:t>
+                        </m:r>
+                      </m:e>
+                      <m:sub>
+                        <m:r>
+                          <a:rPr lang="de-DE" b="0" i="1" smtClean="0">
+                            <a:latin typeface="Cambria Math" panose="02040503050406030204" pitchFamily="18" charset="0"/>
+                          </a:rPr>
+                          <m:t>2</m:t>
+                        </m:r>
+                      </m:sub>
+                    </m:sSub>
+                  </m:oMath>
+                </a14:m>
+                <a:r>
+                  <a:rPr lang="de-DE" dirty="0"/>
+                  <a:t>	node2: </a:t>
+                </a:r>
+                <a14:m>
+                  <m:oMath xmlns:m="http://schemas.openxmlformats.org/officeDocument/2006/math">
+                    <m:sSub>
+                      <m:sSubPr>
+                        <m:ctrlPr>
+                          <a:rPr lang="de-DE" i="1" smtClean="0">
+                            <a:latin typeface="Cambria Math" panose="02040503050406030204" pitchFamily="18" charset="0"/>
+                          </a:rPr>
+                        </m:ctrlPr>
+                      </m:sSubPr>
+                      <m:e>
+                        <m:r>
+                          <a:rPr lang="de-DE" b="0" i="1" smtClean="0">
+                            <a:latin typeface="Cambria Math" panose="02040503050406030204" pitchFamily="18" charset="0"/>
+                          </a:rPr>
+                          <m:t>𝐼</m:t>
+                        </m:r>
+                      </m:e>
+                      <m:sub>
+                        <m:r>
+                          <a:rPr lang="de-DE" b="0" i="1" smtClean="0">
+                            <a:latin typeface="Cambria Math" panose="02040503050406030204" pitchFamily="18" charset="0"/>
+                          </a:rPr>
+                          <m:t>2</m:t>
+                        </m:r>
+                      </m:sub>
+                    </m:sSub>
+                    <m:r>
+                      <a:rPr lang="de-DE" b="0" i="1" smtClean="0">
+                        <a:latin typeface="Cambria Math" panose="02040503050406030204" pitchFamily="18" charset="0"/>
+                      </a:rPr>
+                      <m:t>+</m:t>
+                    </m:r>
+                    <m:sSub>
+                      <m:sSubPr>
+                        <m:ctrlPr>
+                          <a:rPr lang="de-DE" b="0" i="1" smtClean="0">
+                            <a:latin typeface="Cambria Math" panose="02040503050406030204" pitchFamily="18" charset="0"/>
+                          </a:rPr>
+                        </m:ctrlPr>
+                      </m:sSubPr>
+                      <m:e>
+                        <m:r>
+                          <a:rPr lang="de-DE" b="0" i="1" smtClean="0">
+                            <a:latin typeface="Cambria Math" panose="02040503050406030204" pitchFamily="18" charset="0"/>
+                          </a:rPr>
+                          <m:t>𝑖</m:t>
+                        </m:r>
+                      </m:e>
+                      <m:sub>
+                        <m:r>
+                          <a:rPr lang="de-DE" b="0" i="1" smtClean="0">
+                            <a:latin typeface="Cambria Math" panose="02040503050406030204" pitchFamily="18" charset="0"/>
+                          </a:rPr>
+                          <m:t>2</m:t>
+                        </m:r>
+                      </m:sub>
+                    </m:sSub>
+                    <m:r>
+                      <a:rPr lang="de-DE" b="0" i="1" smtClean="0">
+                        <a:latin typeface="Cambria Math" panose="02040503050406030204" pitchFamily="18" charset="0"/>
+                      </a:rPr>
+                      <m:t>=</m:t>
+                    </m:r>
+                    <m:sSub>
+                      <m:sSubPr>
+                        <m:ctrlPr>
+                          <a:rPr lang="de-DE" b="0" i="1" smtClean="0">
+                            <a:latin typeface="Cambria Math" panose="02040503050406030204" pitchFamily="18" charset="0"/>
+                          </a:rPr>
+                        </m:ctrlPr>
+                      </m:sSubPr>
+                      <m:e>
+                        <m:r>
+                          <a:rPr lang="de-DE" b="0" i="1" smtClean="0">
+                            <a:latin typeface="Cambria Math" panose="02040503050406030204" pitchFamily="18" charset="0"/>
+                          </a:rPr>
+                          <m:t>𝑖</m:t>
+                        </m:r>
+                      </m:e>
+                      <m:sub>
+                        <m:r>
+                          <a:rPr lang="de-DE" b="0" i="1" smtClean="0">
+                            <a:latin typeface="Cambria Math" panose="02040503050406030204" pitchFamily="18" charset="0"/>
+                          </a:rPr>
+                          <m:t>3</m:t>
+                        </m:r>
+                      </m:sub>
+                    </m:sSub>
+                  </m:oMath>
+                </a14:m>
+                <a:endParaRPr lang="de-DE" dirty="0"/>
+              </a:p>
+            </p:txBody>
+          </p:sp>
+        </mc:Choice>
+        <mc:Fallback>
+          <p:sp>
+            <p:nvSpPr>
+              <p:cNvPr id="27" name="Textfeld 26">
+                <a:extLst>
+                  <a:ext uri="{FF2B5EF4-FFF2-40B4-BE49-F238E27FC236}">
+                    <a16:creationId xmlns:a16="http://schemas.microsoft.com/office/drawing/2014/main" id="{F84AF832-11DD-714E-68B6-F1EE3DCAFE47}"/>
+                  </a:ext>
+                </a:extLst>
+              </p:cNvPr>
+              <p:cNvSpPr txBox="1">
+                <a:spLocks noRot="1" noChangeAspect="1" noMove="1" noResize="1" noEditPoints="1" noAdjustHandles="1" noChangeArrowheads="1" noChangeShapeType="1" noTextEdit="1"/>
+              </p:cNvSpPr>
+              <p:nvPr/>
+            </p:nvSpPr>
+            <p:spPr>
+              <a:xfrm>
+                <a:off x="838200" y="4176001"/>
+                <a:ext cx="5935343" cy="369332"/>
+              </a:xfrm>
+              <a:prstGeom prst="rect">
+                <a:avLst/>
+              </a:prstGeom>
+              <a:blipFill>
+                <a:blip r:embed="rId3"/>
+                <a:stretch>
+                  <a:fillRect l="-853" t="-6452" b="-22581"/>
+                </a:stretch>
+              </a:blipFill>
+              <a:ln>
+                <a:solidFill>
+                  <a:schemeClr val="tx1"/>
+                </a:solidFill>
+              </a:ln>
+            </p:spPr>
+            <p:txBody>
+              <a:bodyPr/>
+              <a:lstStyle/>
+              <a:p>
+                <a:r>
+                  <a:rPr lang="de-DE">
+                    <a:noFill/>
+                  </a:rPr>
+                  <a:t> </a:t>
+                </a:r>
+              </a:p>
+            </p:txBody>
+          </p:sp>
+        </mc:Fallback>
+      </mc:AlternateContent>
+      <p:sp>
+        <p:nvSpPr>
+          <p:cNvPr id="2" name="Titel 1">
+            <a:extLst>
+              <a:ext uri="{FF2B5EF4-FFF2-40B4-BE49-F238E27FC236}">
+                <a16:creationId xmlns:a16="http://schemas.microsoft.com/office/drawing/2014/main" id="{CAB5C406-365F-B1B1-05B8-69E02AA624CF}"/>
+              </a:ext>
+            </a:extLst>
+          </p:cNvPr>
+          <p:cNvSpPr>
+            <a:spLocks noGrp="1"/>
+          </p:cNvSpPr>
+          <p:nvPr>
+            <p:ph type="title"/>
+          </p:nvPr>
+        </p:nvSpPr>
+        <p:spPr/>
+        <p:txBody>
+          <a:bodyPr/>
+          <a:lstStyle/>
+          <a:p>
+            <a:r>
+              <a:rPr lang="de-DE" dirty="0"/>
+              <a:t>Alternative: </a:t>
+            </a:r>
+            <a:r>
+              <a:rPr lang="de-DE" dirty="0" err="1"/>
+              <a:t>Nodal</a:t>
+            </a:r>
+            <a:r>
+              <a:rPr lang="de-DE" dirty="0"/>
+              <a:t> Analysis</a:t>
+            </a:r>
+          </a:p>
+        </p:txBody>
+      </p:sp>
+      <p:sp>
+        <p:nvSpPr>
+          <p:cNvPr id="3" name="Foliennummernplatzhalter 2">
+            <a:extLst>
+              <a:ext uri="{FF2B5EF4-FFF2-40B4-BE49-F238E27FC236}">
+                <a16:creationId xmlns:a16="http://schemas.microsoft.com/office/drawing/2014/main" id="{445A0059-57CB-21C4-7894-37E7247EA417}"/>
+              </a:ext>
+            </a:extLst>
+          </p:cNvPr>
+          <p:cNvSpPr>
+            <a:spLocks noGrp="1"/>
+          </p:cNvSpPr>
+          <p:nvPr>
+            <p:ph type="sldNum" sz="quarter" idx="12"/>
+          </p:nvPr>
+        </p:nvSpPr>
+        <p:spPr/>
+        <p:txBody>
+          <a:bodyPr/>
+          <a:lstStyle/>
+          <a:p>
+            <a:fld id="{BA3EAA6B-85FB-CD46-8BDC-C1BC3364C8C0}" type="slidenum">
+              <a:rPr lang="de-DE" smtClean="0"/>
+              <a:t>28</a:t>
+            </a:fld>
+            <a:endParaRPr lang="de-DE"/>
+          </a:p>
+        </p:txBody>
+      </p:sp>
+      <p:pic>
+        <p:nvPicPr>
+          <p:cNvPr id="6" name="Grafik 5" descr="Ein Bild, das Diagramm, Reihe enthält.&#10;&#10;KI-generierte Inhalte können fehlerhaft sein.">
+            <a:extLst>
+              <a:ext uri="{FF2B5EF4-FFF2-40B4-BE49-F238E27FC236}">
+                <a16:creationId xmlns:a16="http://schemas.microsoft.com/office/drawing/2014/main" id="{E0AA889E-3275-DD0C-5F8B-9E6E60623D04}"/>
+              </a:ext>
+            </a:extLst>
+          </p:cNvPr>
+          <p:cNvPicPr>
+            <a:picLocks noChangeAspect="1"/>
+          </p:cNvPicPr>
+          <p:nvPr/>
+        </p:nvPicPr>
+        <p:blipFill>
+          <a:blip r:embed="rId4"/>
+          <a:stretch>
+            <a:fillRect/>
+          </a:stretch>
+        </p:blipFill>
+        <p:spPr>
+          <a:xfrm>
+            <a:off x="9088511" y="721782"/>
+            <a:ext cx="2560144" cy="2508393"/>
+          </a:xfrm>
+          <a:prstGeom prst="rect">
+            <a:avLst/>
+          </a:prstGeom>
+        </p:spPr>
+      </p:pic>
+      <p:pic>
+        <p:nvPicPr>
+          <p:cNvPr id="8" name="Grafik 7" descr="Ein Bild, das Diagramm, Text enthält.&#10;&#10;KI-generierte Inhalte können fehlerhaft sein.">
+            <a:extLst>
+              <a:ext uri="{FF2B5EF4-FFF2-40B4-BE49-F238E27FC236}">
+                <a16:creationId xmlns:a16="http://schemas.microsoft.com/office/drawing/2014/main" id="{B4A7DFB5-7DB8-79BE-8FBE-07856800B2E3}"/>
+              </a:ext>
+            </a:extLst>
+          </p:cNvPr>
+          <p:cNvPicPr>
+            <a:picLocks noChangeAspect="1"/>
+          </p:cNvPicPr>
+          <p:nvPr/>
+        </p:nvPicPr>
+        <p:blipFill>
+          <a:blip r:embed="rId5"/>
+          <a:stretch>
+            <a:fillRect/>
+          </a:stretch>
+        </p:blipFill>
+        <p:spPr>
+          <a:xfrm>
+            <a:off x="9088511" y="3997157"/>
+            <a:ext cx="2560144" cy="2179806"/>
+          </a:xfrm>
+          <a:prstGeom prst="rect">
+            <a:avLst/>
+          </a:prstGeom>
+        </p:spPr>
+      </p:pic>
+      <p:sp>
+        <p:nvSpPr>
+          <p:cNvPr id="9" name="Textfeld 8">
+            <a:extLst>
+              <a:ext uri="{FF2B5EF4-FFF2-40B4-BE49-F238E27FC236}">
+                <a16:creationId xmlns:a16="http://schemas.microsoft.com/office/drawing/2014/main" id="{F6ACD28B-5E4E-4F42-72B2-BCC8C82B7505}"/>
+              </a:ext>
+            </a:extLst>
+          </p:cNvPr>
+          <p:cNvSpPr txBox="1"/>
+          <p:nvPr/>
+        </p:nvSpPr>
+        <p:spPr>
+          <a:xfrm>
+            <a:off x="9395218" y="3627825"/>
+            <a:ext cx="2414572" cy="369332"/>
+          </a:xfrm>
+          <a:prstGeom prst="rect">
+            <a:avLst/>
+          </a:prstGeom>
+          <a:noFill/>
+        </p:spPr>
+        <p:txBody>
+          <a:bodyPr wrap="none" rtlCol="0">
+            <a:spAutoFit/>
+          </a:bodyPr>
+          <a:lstStyle/>
+          <a:p>
+            <a:r>
+              <a:rPr lang="de-DE" dirty="0" err="1"/>
+              <a:t>redrawn</a:t>
+            </a:r>
+            <a:r>
+              <a:rPr lang="de-DE" dirty="0"/>
+              <a:t> </a:t>
+            </a:r>
+            <a:r>
+              <a:rPr lang="de-DE" dirty="0" err="1"/>
+              <a:t>with</a:t>
+            </a:r>
+            <a:r>
+              <a:rPr lang="de-DE" dirty="0"/>
+              <a:t> </a:t>
+            </a:r>
+            <a:r>
+              <a:rPr lang="de-DE" dirty="0" err="1"/>
+              <a:t>currents</a:t>
+            </a:r>
+            <a:r>
+              <a:rPr lang="de-DE" dirty="0"/>
+              <a:t>:</a:t>
+            </a:r>
+          </a:p>
+        </p:txBody>
+      </p:sp>
+      <p:cxnSp>
+        <p:nvCxnSpPr>
+          <p:cNvPr id="11" name="Gerade Verbindung mit Pfeil 10">
+            <a:extLst>
+              <a:ext uri="{FF2B5EF4-FFF2-40B4-BE49-F238E27FC236}">
+                <a16:creationId xmlns:a16="http://schemas.microsoft.com/office/drawing/2014/main" id="{909F1F47-E6B0-E2A4-C4FF-1A7E8B57A5DC}"/>
+              </a:ext>
+            </a:extLst>
+          </p:cNvPr>
+          <p:cNvCxnSpPr>
+            <a:cxnSpLocks/>
+          </p:cNvCxnSpPr>
+          <p:nvPr/>
+        </p:nvCxnSpPr>
+        <p:spPr>
+          <a:xfrm>
+            <a:off x="4433777" y="2998381"/>
+            <a:ext cx="5571460" cy="105268"/>
+          </a:xfrm>
+          <a:prstGeom prst="straightConnector1">
+            <a:avLst/>
+          </a:prstGeom>
+          <a:ln>
+            <a:tailEnd type="triangle"/>
+          </a:ln>
+        </p:spPr>
+        <p:style>
+          <a:lnRef idx="2">
+            <a:schemeClr val="accent1"/>
+          </a:lnRef>
+          <a:fillRef idx="0">
+            <a:schemeClr val="accent1"/>
+          </a:fillRef>
+          <a:effectRef idx="1">
+            <a:schemeClr val="accent1"/>
+          </a:effectRef>
+          <a:fontRef idx="minor">
+            <a:schemeClr val="tx1"/>
+          </a:fontRef>
+        </p:style>
+      </p:cxnSp>
+      <mc:AlternateContent xmlns:mc="http://schemas.openxmlformats.org/markup-compatibility/2006">
+        <mc:Choice xmlns:a14="http://schemas.microsoft.com/office/drawing/2010/main" Requires="a14">
+          <p:sp>
+            <p:nvSpPr>
+              <p:cNvPr id="28" name="Textfeld 27">
+                <a:extLst>
+                  <a:ext uri="{FF2B5EF4-FFF2-40B4-BE49-F238E27FC236}">
+                    <a16:creationId xmlns:a16="http://schemas.microsoft.com/office/drawing/2014/main" id="{F50CCCB4-A6CD-5F4C-D303-4E63626C671B}"/>
+                  </a:ext>
+                </a:extLst>
+              </p:cNvPr>
+              <p:cNvSpPr txBox="1"/>
+              <p:nvPr/>
+            </p:nvSpPr>
+            <p:spPr>
+              <a:xfrm>
+                <a:off x="4085954" y="5438675"/>
+                <a:ext cx="4336700" cy="529440"/>
+              </a:xfrm>
+              <a:prstGeom prst="rect">
+                <a:avLst/>
+              </a:prstGeom>
+              <a:noFill/>
+              <a:ln>
+                <a:solidFill>
+                  <a:schemeClr val="tx1"/>
+                </a:solidFill>
+              </a:ln>
+            </p:spPr>
+            <p:txBody>
+              <a:bodyPr wrap="none" rtlCol="0">
+                <a:spAutoFit/>
+              </a:bodyPr>
+              <a:lstStyle/>
+              <a:p>
+                <a:r>
+                  <a:rPr lang="de-DE" dirty="0"/>
+                  <a:t>here:	</a:t>
+                </a:r>
+                <a14:m>
+                  <m:oMath xmlns:m="http://schemas.openxmlformats.org/officeDocument/2006/math">
+                    <m:sSub>
+                      <m:sSubPr>
+                        <m:ctrlPr>
+                          <a:rPr lang="de-DE" i="1" smtClean="0">
+                            <a:latin typeface="Cambria Math" panose="02040503050406030204" pitchFamily="18" charset="0"/>
+                          </a:rPr>
+                        </m:ctrlPr>
+                      </m:sSubPr>
+                      <m:e>
+                        <m:r>
+                          <a:rPr lang="de-DE" b="0" i="1" smtClean="0">
+                            <a:latin typeface="Cambria Math" panose="02040503050406030204" pitchFamily="18" charset="0"/>
+                          </a:rPr>
+                          <m:t>𝑖</m:t>
+                        </m:r>
+                      </m:e>
+                      <m:sub>
+                        <m:r>
+                          <a:rPr lang="de-DE" b="0" i="1" smtClean="0">
+                            <a:latin typeface="Cambria Math" panose="02040503050406030204" pitchFamily="18" charset="0"/>
+                          </a:rPr>
+                          <m:t>1</m:t>
+                        </m:r>
+                      </m:sub>
+                    </m:sSub>
+                    <m:r>
+                      <a:rPr lang="de-DE" b="0" i="1" smtClean="0">
+                        <a:latin typeface="Cambria Math" panose="02040503050406030204" pitchFamily="18" charset="0"/>
+                      </a:rPr>
+                      <m:t>=</m:t>
+                    </m:r>
+                    <m:f>
+                      <m:fPr>
+                        <m:ctrlPr>
+                          <a:rPr lang="de-DE" b="0" i="1" smtClean="0">
+                            <a:latin typeface="Cambria Math" panose="02040503050406030204" pitchFamily="18" charset="0"/>
+                          </a:rPr>
+                        </m:ctrlPr>
+                      </m:fPr>
+                      <m:num>
+                        <m:sSub>
+                          <m:sSubPr>
+                            <m:ctrlPr>
+                              <a:rPr lang="de-DE" b="0" i="1" smtClean="0">
+                                <a:latin typeface="Cambria Math" panose="02040503050406030204" pitchFamily="18" charset="0"/>
+                              </a:rPr>
+                            </m:ctrlPr>
+                          </m:sSubPr>
+                          <m:e>
+                            <m:r>
+                              <a:rPr lang="de-DE" b="0" i="1" smtClean="0">
+                                <a:latin typeface="Cambria Math" panose="02040503050406030204" pitchFamily="18" charset="0"/>
+                              </a:rPr>
+                              <m:t>𝑣</m:t>
+                            </m:r>
+                          </m:e>
+                          <m:sub>
+                            <m:r>
+                              <a:rPr lang="de-DE" b="0" i="1" smtClean="0">
+                                <a:latin typeface="Cambria Math" panose="02040503050406030204" pitchFamily="18" charset="0"/>
+                              </a:rPr>
+                              <m:t>1</m:t>
+                            </m:r>
+                          </m:sub>
+                        </m:sSub>
+                        <m:r>
+                          <a:rPr lang="de-DE" b="0" i="1" smtClean="0">
+                            <a:latin typeface="Cambria Math" panose="02040503050406030204" pitchFamily="18" charset="0"/>
+                          </a:rPr>
+                          <m:t>−0</m:t>
+                        </m:r>
+                      </m:num>
+                      <m:den>
+                        <m:sSub>
+                          <m:sSubPr>
+                            <m:ctrlPr>
+                              <a:rPr lang="de-DE" b="0" i="1" smtClean="0">
+                                <a:latin typeface="Cambria Math" panose="02040503050406030204" pitchFamily="18" charset="0"/>
+                              </a:rPr>
+                            </m:ctrlPr>
+                          </m:sSubPr>
+                          <m:e>
+                            <m:r>
+                              <a:rPr lang="de-DE" b="0" i="1" smtClean="0">
+                                <a:latin typeface="Cambria Math" panose="02040503050406030204" pitchFamily="18" charset="0"/>
+                              </a:rPr>
+                              <m:t>𝑅</m:t>
+                            </m:r>
+                          </m:e>
+                          <m:sub>
+                            <m:r>
+                              <a:rPr lang="de-DE" b="0" i="1" smtClean="0">
+                                <a:latin typeface="Cambria Math" panose="02040503050406030204" pitchFamily="18" charset="0"/>
+                              </a:rPr>
+                              <m:t>1</m:t>
+                            </m:r>
+                          </m:sub>
+                        </m:sSub>
+                      </m:den>
+                    </m:f>
+                  </m:oMath>
+                </a14:m>
+                <a:r>
+                  <a:rPr lang="de-DE" dirty="0"/>
+                  <a:t>	    </a:t>
+                </a:r>
+                <a14:m>
+                  <m:oMath xmlns:m="http://schemas.openxmlformats.org/officeDocument/2006/math">
+                    <m:sSub>
+                      <m:sSubPr>
+                        <m:ctrlPr>
+                          <a:rPr lang="de-DE" i="1">
+                            <a:latin typeface="Cambria Math" panose="02040503050406030204" pitchFamily="18" charset="0"/>
+                          </a:rPr>
+                        </m:ctrlPr>
+                      </m:sSubPr>
+                      <m:e>
+                        <m:r>
+                          <a:rPr lang="de-DE" i="1">
+                            <a:latin typeface="Cambria Math" panose="02040503050406030204" pitchFamily="18" charset="0"/>
+                          </a:rPr>
+                          <m:t>𝑖</m:t>
+                        </m:r>
+                      </m:e>
+                      <m:sub>
+                        <m:r>
+                          <a:rPr lang="de-DE" b="0" i="1" smtClean="0">
+                            <a:latin typeface="Cambria Math" panose="02040503050406030204" pitchFamily="18" charset="0"/>
+                          </a:rPr>
+                          <m:t>2</m:t>
+                        </m:r>
+                      </m:sub>
+                    </m:sSub>
+                    <m:r>
+                      <a:rPr lang="de-DE" i="1">
+                        <a:latin typeface="Cambria Math" panose="02040503050406030204" pitchFamily="18" charset="0"/>
+                      </a:rPr>
+                      <m:t>=</m:t>
+                    </m:r>
+                    <m:f>
+                      <m:fPr>
+                        <m:ctrlPr>
+                          <a:rPr lang="de-DE" i="1">
+                            <a:latin typeface="Cambria Math" panose="02040503050406030204" pitchFamily="18" charset="0"/>
+                          </a:rPr>
+                        </m:ctrlPr>
+                      </m:fPr>
+                      <m:num>
+                        <m:sSub>
+                          <m:sSubPr>
+                            <m:ctrlPr>
+                              <a:rPr lang="de-DE" i="1">
+                                <a:latin typeface="Cambria Math" panose="02040503050406030204" pitchFamily="18" charset="0"/>
+                              </a:rPr>
+                            </m:ctrlPr>
+                          </m:sSubPr>
+                          <m:e>
+                            <m:r>
+                              <a:rPr lang="de-DE" i="1">
+                                <a:latin typeface="Cambria Math" panose="02040503050406030204" pitchFamily="18" charset="0"/>
+                              </a:rPr>
+                              <m:t>𝑣</m:t>
+                            </m:r>
+                          </m:e>
+                          <m:sub>
+                            <m:r>
+                              <a:rPr lang="de-DE" i="1">
+                                <a:latin typeface="Cambria Math" panose="02040503050406030204" pitchFamily="18" charset="0"/>
+                              </a:rPr>
+                              <m:t>1</m:t>
+                            </m:r>
+                          </m:sub>
+                        </m:sSub>
+                        <m:r>
+                          <a:rPr lang="de-DE" i="1">
+                            <a:latin typeface="Cambria Math" panose="02040503050406030204" pitchFamily="18" charset="0"/>
+                          </a:rPr>
+                          <m:t>−</m:t>
+                        </m:r>
+                        <m:sSub>
+                          <m:sSubPr>
+                            <m:ctrlPr>
+                              <a:rPr lang="de-DE" i="1" smtClean="0">
+                                <a:latin typeface="Cambria Math" panose="02040503050406030204" pitchFamily="18" charset="0"/>
+                              </a:rPr>
+                            </m:ctrlPr>
+                          </m:sSubPr>
+                          <m:e>
+                            <m:r>
+                              <a:rPr lang="de-DE" b="0" i="1" smtClean="0">
+                                <a:latin typeface="Cambria Math" panose="02040503050406030204" pitchFamily="18" charset="0"/>
+                              </a:rPr>
+                              <m:t>𝑣</m:t>
+                            </m:r>
+                          </m:e>
+                          <m:sub>
+                            <m:r>
+                              <a:rPr lang="de-DE" b="0" i="1" smtClean="0">
+                                <a:latin typeface="Cambria Math" panose="02040503050406030204" pitchFamily="18" charset="0"/>
+                              </a:rPr>
+                              <m:t>2</m:t>
+                            </m:r>
+                          </m:sub>
+                        </m:sSub>
+                      </m:num>
+                      <m:den>
+                        <m:sSub>
+                          <m:sSubPr>
+                            <m:ctrlPr>
+                              <a:rPr lang="de-DE" i="1">
+                                <a:latin typeface="Cambria Math" panose="02040503050406030204" pitchFamily="18" charset="0"/>
+                              </a:rPr>
+                            </m:ctrlPr>
+                          </m:sSubPr>
+                          <m:e>
+                            <m:r>
+                              <a:rPr lang="de-DE" i="1">
+                                <a:latin typeface="Cambria Math" panose="02040503050406030204" pitchFamily="18" charset="0"/>
+                              </a:rPr>
+                              <m:t>𝑅</m:t>
+                            </m:r>
+                          </m:e>
+                          <m:sub>
+                            <m:r>
+                              <a:rPr lang="de-DE" b="0" i="1" smtClean="0">
+                                <a:latin typeface="Cambria Math" panose="02040503050406030204" pitchFamily="18" charset="0"/>
+                              </a:rPr>
+                              <m:t>2</m:t>
+                            </m:r>
+                          </m:sub>
+                        </m:sSub>
+                      </m:den>
+                    </m:f>
+                  </m:oMath>
+                </a14:m>
+                <a:r>
+                  <a:rPr lang="de-DE" dirty="0"/>
+                  <a:t>      </a:t>
+                </a:r>
+                <a14:m>
+                  <m:oMath xmlns:m="http://schemas.openxmlformats.org/officeDocument/2006/math">
+                    <m:sSub>
+                      <m:sSubPr>
+                        <m:ctrlPr>
+                          <a:rPr lang="de-DE" i="1">
+                            <a:latin typeface="Cambria Math" panose="02040503050406030204" pitchFamily="18" charset="0"/>
+                          </a:rPr>
+                        </m:ctrlPr>
+                      </m:sSubPr>
+                      <m:e>
+                        <m:r>
+                          <a:rPr lang="de-DE" i="1">
+                            <a:latin typeface="Cambria Math" panose="02040503050406030204" pitchFamily="18" charset="0"/>
+                          </a:rPr>
+                          <m:t>𝑖</m:t>
+                        </m:r>
+                      </m:e>
+                      <m:sub>
+                        <m:r>
+                          <a:rPr lang="de-DE" b="0" i="1" smtClean="0">
+                            <a:latin typeface="Cambria Math" panose="02040503050406030204" pitchFamily="18" charset="0"/>
+                          </a:rPr>
+                          <m:t>3</m:t>
+                        </m:r>
+                      </m:sub>
+                    </m:sSub>
+                    <m:r>
+                      <a:rPr lang="de-DE" i="1">
+                        <a:latin typeface="Cambria Math" panose="02040503050406030204" pitchFamily="18" charset="0"/>
+                      </a:rPr>
+                      <m:t>=</m:t>
+                    </m:r>
+                    <m:f>
+                      <m:fPr>
+                        <m:ctrlPr>
+                          <a:rPr lang="de-DE" i="1">
+                            <a:latin typeface="Cambria Math" panose="02040503050406030204" pitchFamily="18" charset="0"/>
+                          </a:rPr>
+                        </m:ctrlPr>
+                      </m:fPr>
+                      <m:num>
+                        <m:sSub>
+                          <m:sSubPr>
+                            <m:ctrlPr>
+                              <a:rPr lang="de-DE" i="1">
+                                <a:latin typeface="Cambria Math" panose="02040503050406030204" pitchFamily="18" charset="0"/>
+                              </a:rPr>
+                            </m:ctrlPr>
+                          </m:sSubPr>
+                          <m:e>
+                            <m:r>
+                              <a:rPr lang="de-DE" i="1">
+                                <a:latin typeface="Cambria Math" panose="02040503050406030204" pitchFamily="18" charset="0"/>
+                              </a:rPr>
+                              <m:t>𝑣</m:t>
+                            </m:r>
+                          </m:e>
+                          <m:sub>
+                            <m:r>
+                              <a:rPr lang="de-DE" b="0" i="1" smtClean="0">
+                                <a:latin typeface="Cambria Math" panose="02040503050406030204" pitchFamily="18" charset="0"/>
+                              </a:rPr>
+                              <m:t>2</m:t>
+                            </m:r>
+                          </m:sub>
+                        </m:sSub>
+                        <m:r>
+                          <a:rPr lang="de-DE" i="1">
+                            <a:latin typeface="Cambria Math" panose="02040503050406030204" pitchFamily="18" charset="0"/>
+                          </a:rPr>
+                          <m:t>−0</m:t>
+                        </m:r>
+                      </m:num>
+                      <m:den>
+                        <m:sSub>
+                          <m:sSubPr>
+                            <m:ctrlPr>
+                              <a:rPr lang="de-DE" i="1">
+                                <a:latin typeface="Cambria Math" panose="02040503050406030204" pitchFamily="18" charset="0"/>
+                              </a:rPr>
+                            </m:ctrlPr>
+                          </m:sSubPr>
+                          <m:e>
+                            <m:r>
+                              <a:rPr lang="de-DE" i="1">
+                                <a:latin typeface="Cambria Math" panose="02040503050406030204" pitchFamily="18" charset="0"/>
+                              </a:rPr>
+                              <m:t>𝑅</m:t>
+                            </m:r>
+                          </m:e>
+                          <m:sub>
+                            <m:r>
+                              <a:rPr lang="de-DE" b="0" i="1" smtClean="0">
+                                <a:latin typeface="Cambria Math" panose="02040503050406030204" pitchFamily="18" charset="0"/>
+                              </a:rPr>
+                              <m:t>3</m:t>
+                            </m:r>
+                          </m:sub>
+                        </m:sSub>
+                      </m:den>
+                    </m:f>
+                  </m:oMath>
+                </a14:m>
+                <a:endParaRPr lang="de-DE" dirty="0"/>
+              </a:p>
+            </p:txBody>
+          </p:sp>
+        </mc:Choice>
+        <mc:Fallback>
+          <p:sp>
+            <p:nvSpPr>
+              <p:cNvPr id="28" name="Textfeld 27">
+                <a:extLst>
+                  <a:ext uri="{FF2B5EF4-FFF2-40B4-BE49-F238E27FC236}">
+                    <a16:creationId xmlns:a16="http://schemas.microsoft.com/office/drawing/2014/main" id="{F50CCCB4-A6CD-5F4C-D303-4E63626C671B}"/>
+                  </a:ext>
+                </a:extLst>
+              </p:cNvPr>
+              <p:cNvSpPr txBox="1">
+                <a:spLocks noRot="1" noChangeAspect="1" noMove="1" noResize="1" noEditPoints="1" noAdjustHandles="1" noChangeArrowheads="1" noChangeShapeType="1" noTextEdit="1"/>
+              </p:cNvSpPr>
+              <p:nvPr/>
+            </p:nvSpPr>
+            <p:spPr>
+              <a:xfrm>
+                <a:off x="4085954" y="5438675"/>
+                <a:ext cx="4336700" cy="529440"/>
+              </a:xfrm>
+              <a:prstGeom prst="rect">
+                <a:avLst/>
+              </a:prstGeom>
+              <a:blipFill>
+                <a:blip r:embed="rId6"/>
+                <a:stretch>
+                  <a:fillRect l="-1166"/>
+                </a:stretch>
+              </a:blipFill>
+              <a:ln>
+                <a:solidFill>
+                  <a:schemeClr val="tx1"/>
+                </a:solidFill>
+              </a:ln>
+            </p:spPr>
+            <p:txBody>
+              <a:bodyPr/>
+              <a:lstStyle/>
+              <a:p>
+                <a:r>
+                  <a:rPr lang="de-DE">
+                    <a:noFill/>
+                  </a:rPr>
+                  <a:t> </a:t>
+                </a:r>
+              </a:p>
+            </p:txBody>
+          </p:sp>
+        </mc:Fallback>
+      </mc:AlternateContent>
+      <mc:AlternateContent xmlns:mc="http://schemas.openxmlformats.org/markup-compatibility/2006">
+        <mc:Choice xmlns:a14="http://schemas.microsoft.com/office/drawing/2010/main" Requires="a14">
+          <p:sp>
+            <p:nvSpPr>
+              <p:cNvPr id="5" name="Textfeld 4">
+                <a:extLst>
+                  <a:ext uri="{FF2B5EF4-FFF2-40B4-BE49-F238E27FC236}">
+                    <a16:creationId xmlns:a16="http://schemas.microsoft.com/office/drawing/2014/main" id="{5A072E3D-0314-772B-BB71-18E9441C8815}"/>
+                  </a:ext>
+                </a:extLst>
+              </p:cNvPr>
+              <p:cNvSpPr txBox="1"/>
+              <p:nvPr/>
+            </p:nvSpPr>
+            <p:spPr>
+              <a:xfrm>
+                <a:off x="789569" y="5323154"/>
+                <a:ext cx="2630528" cy="646524"/>
+              </a:xfrm>
+              <a:prstGeom prst="rect">
+                <a:avLst/>
+              </a:prstGeom>
+              <a:noFill/>
+              <a:ln>
+                <a:noFill/>
+              </a:ln>
+            </p:spPr>
+            <p:txBody>
+              <a:bodyPr wrap="none" lIns="0" tIns="0" rIns="0" bIns="0" rtlCol="0">
+                <a:spAutoFit/>
+              </a:bodyPr>
+              <a:lstStyle/>
+              <a:p>
+                <a14:m>
+                  <m:oMathPara xmlns:m="http://schemas.openxmlformats.org/officeDocument/2006/math">
+                    <m:oMathParaPr>
+                      <m:jc m:val="centerGroup"/>
+                    </m:oMathParaPr>
+                    <m:oMath xmlns:m="http://schemas.openxmlformats.org/officeDocument/2006/math">
+                      <m:r>
+                        <a:rPr lang="de-DE" sz="2400" b="0" i="1" smtClean="0">
+                          <a:latin typeface="Cambria Math" panose="02040503050406030204" pitchFamily="18" charset="0"/>
+                        </a:rPr>
+                        <m:t>𝑖</m:t>
+                      </m:r>
+                      <m:r>
+                        <a:rPr lang="de-DE" sz="2400" b="0" i="1" smtClean="0">
+                          <a:latin typeface="Cambria Math" panose="02040503050406030204" pitchFamily="18" charset="0"/>
+                        </a:rPr>
+                        <m:t>=</m:t>
+                      </m:r>
+                      <m:f>
+                        <m:fPr>
+                          <m:ctrlPr>
+                            <a:rPr lang="de-DE" sz="2400" b="0" i="1" smtClean="0">
+                              <a:latin typeface="Cambria Math" panose="02040503050406030204" pitchFamily="18" charset="0"/>
+                            </a:rPr>
+                          </m:ctrlPr>
+                        </m:fPr>
+                        <m:num>
+                          <m:sSub>
+                            <m:sSubPr>
+                              <m:ctrlPr>
+                                <a:rPr lang="de-DE" sz="2400" b="0" i="1" smtClean="0">
+                                  <a:latin typeface="Cambria Math" panose="02040503050406030204" pitchFamily="18" charset="0"/>
+                                </a:rPr>
+                              </m:ctrlPr>
+                            </m:sSubPr>
+                            <m:e>
+                              <m:r>
+                                <a:rPr lang="de-DE" sz="2400" b="0" i="1" smtClean="0">
+                                  <a:latin typeface="Cambria Math" panose="02040503050406030204" pitchFamily="18" charset="0"/>
+                                </a:rPr>
+                                <m:t>𝑣</m:t>
+                              </m:r>
+                            </m:e>
+                            <m:sub>
+                              <m:r>
+                                <m:rPr>
+                                  <m:sty m:val="p"/>
+                                </m:rPr>
+                                <a:rPr lang="de-DE" sz="2400" b="0" i="0" smtClean="0">
+                                  <a:latin typeface="Cambria Math" panose="02040503050406030204" pitchFamily="18" charset="0"/>
+                                </a:rPr>
+                                <m:t>higher</m:t>
+                              </m:r>
+                            </m:sub>
+                          </m:sSub>
+                          <m:r>
+                            <a:rPr lang="de-DE" sz="2400" b="0" i="1" smtClean="0">
+                              <a:latin typeface="Cambria Math" panose="02040503050406030204" pitchFamily="18" charset="0"/>
+                            </a:rPr>
+                            <m:t>−</m:t>
+                          </m:r>
+                          <m:sSub>
+                            <m:sSubPr>
+                              <m:ctrlPr>
+                                <a:rPr lang="de-DE" sz="2400" b="0" i="1" smtClean="0">
+                                  <a:latin typeface="Cambria Math" panose="02040503050406030204" pitchFamily="18" charset="0"/>
+                                </a:rPr>
+                              </m:ctrlPr>
+                            </m:sSubPr>
+                            <m:e>
+                              <m:r>
+                                <a:rPr lang="de-DE" sz="2400" b="0" i="1" smtClean="0">
+                                  <a:latin typeface="Cambria Math" panose="02040503050406030204" pitchFamily="18" charset="0"/>
+                                </a:rPr>
+                                <m:t>𝑣</m:t>
+                              </m:r>
+                            </m:e>
+                            <m:sub>
+                              <m:r>
+                                <m:rPr>
+                                  <m:sty m:val="p"/>
+                                </m:rPr>
+                                <a:rPr lang="de-DE" sz="2400" b="0" i="0" smtClean="0">
+                                  <a:latin typeface="Cambria Math" panose="02040503050406030204" pitchFamily="18" charset="0"/>
+                                </a:rPr>
+                                <m:t>lower</m:t>
+                              </m:r>
+                            </m:sub>
+                          </m:sSub>
+                        </m:num>
+                        <m:den>
+                          <m:r>
+                            <a:rPr lang="de-DE" sz="2400" b="0" i="1" smtClean="0">
+                              <a:latin typeface="Cambria Math" panose="02040503050406030204" pitchFamily="18" charset="0"/>
+                            </a:rPr>
+                            <m:t>𝑅</m:t>
+                          </m:r>
+                        </m:den>
+                      </m:f>
+                    </m:oMath>
+                  </m:oMathPara>
+                </a14:m>
+                <a:endParaRPr lang="de-DE" sz="2400" dirty="0"/>
+              </a:p>
+            </p:txBody>
+          </p:sp>
+        </mc:Choice>
+        <mc:Fallback>
+          <p:sp>
+            <p:nvSpPr>
+              <p:cNvPr id="5" name="Textfeld 4">
+                <a:extLst>
+                  <a:ext uri="{FF2B5EF4-FFF2-40B4-BE49-F238E27FC236}">
+                    <a16:creationId xmlns:a16="http://schemas.microsoft.com/office/drawing/2014/main" id="{5A072E3D-0314-772B-BB71-18E9441C8815}"/>
+                  </a:ext>
+                </a:extLst>
+              </p:cNvPr>
+              <p:cNvSpPr txBox="1">
+                <a:spLocks noRot="1" noChangeAspect="1" noMove="1" noResize="1" noEditPoints="1" noAdjustHandles="1" noChangeArrowheads="1" noChangeShapeType="1" noTextEdit="1"/>
+              </p:cNvSpPr>
+              <p:nvPr/>
+            </p:nvSpPr>
+            <p:spPr>
+              <a:xfrm>
+                <a:off x="789569" y="5323154"/>
+                <a:ext cx="2630528" cy="646524"/>
+              </a:xfrm>
+              <a:prstGeom prst="rect">
+                <a:avLst/>
+              </a:prstGeom>
+              <a:blipFill>
+                <a:blip r:embed="rId7"/>
+                <a:stretch>
+                  <a:fillRect l="-2404" r="-962" b="-15686"/>
+                </a:stretch>
+              </a:blipFill>
+              <a:ln>
+                <a:noFill/>
+              </a:ln>
+            </p:spPr>
+            <p:txBody>
+              <a:bodyPr/>
+              <a:lstStyle/>
+              <a:p>
+                <a:r>
+                  <a:rPr lang="de-DE">
+                    <a:noFill/>
+                  </a:rPr>
+                  <a:t> </a:t>
+                </a:r>
+              </a:p>
+            </p:txBody>
+          </p:sp>
+        </mc:Fallback>
+      </mc:AlternateContent>
+    </p:spTree>
+    <p:extLst>
+      <p:ext uri="{BB962C8B-B14F-4D97-AF65-F5344CB8AC3E}">
+        <p14:creationId xmlns:p14="http://schemas.microsoft.com/office/powerpoint/2010/main" val="14924310"/>
+      </p:ext>
+    </p:extLst>
+  </p:cSld>
+  <p:clrMapOvr>
+    <a:masterClrMapping/>
+  </p:clrMapOvr>
+</p:sld>
+</file>
+
+<file path=ppt/slides/slide29.xml><?xml version="1.0" encoding="utf-8"?>
+<p:sld xmlns:a="http://schemas.openxmlformats.org/drawingml/2006/main" xmlns:r="http://schemas.openxmlformats.org/officeDocument/2006/relationships" xmlns:p="http://schemas.openxmlformats.org/presentationml/2006/main">
+  <p:cSld>
+    <p:spTree>
+      <p:nvGrpSpPr>
+        <p:cNvPr id="1" name=""/>
+        <p:cNvGrpSpPr/>
+        <p:nvPr/>
+      </p:nvGrpSpPr>
+      <p:grpSpPr>
+        <a:xfrm>
+          <a:off x="0" y="0"/>
+          <a:ext cx="0" cy="0"/>
+          <a:chOff x="0" y="0"/>
+          <a:chExt cx="0" cy="0"/>
+        </a:xfrm>
+      </p:grpSpPr>
       <p:sp>
         <p:nvSpPr>
           <p:cNvPr id="2" name="Titel 1">
@@ -21473,7 +23063,7 @@
           <a:p>
             <a:fld id="{BA3EAA6B-85FB-CD46-8BDC-C1BC3364C8C0}" type="slidenum">
               <a:rPr lang="de-DE" smtClean="0"/>
-              <a:t>28</a:t>
+              <a:t>29</a:t>
             </a:fld>
             <a:endParaRPr lang="de-DE"/>
           </a:p>
@@ -21624,7 +23214,263 @@
 </p:sld>
 </file>
 
-<file path=ppt/slides/slide29.xml><?xml version="1.0" encoding="utf-8"?>
+<file path=ppt/slides/slide3.xml><?xml version="1.0" encoding="utf-8"?>
+<p:sld xmlns:a="http://schemas.openxmlformats.org/drawingml/2006/main" xmlns:r="http://schemas.openxmlformats.org/officeDocument/2006/relationships" xmlns:p="http://schemas.openxmlformats.org/presentationml/2006/main">
+  <p:cSld>
+    <p:spTree>
+      <p:nvGrpSpPr>
+        <p:cNvPr id="1" name=""/>
+        <p:cNvGrpSpPr/>
+        <p:nvPr/>
+      </p:nvGrpSpPr>
+      <p:grpSpPr>
+        <a:xfrm>
+          <a:off x="0" y="0"/>
+          <a:ext cx="0" cy="0"/>
+          <a:chOff x="0" y="0"/>
+          <a:chExt cx="0" cy="0"/>
+        </a:xfrm>
+      </p:grpSpPr>
+      <p:sp>
+        <p:nvSpPr>
+          <p:cNvPr id="2" name="Titel 1">
+            <a:extLst>
+              <a:ext uri="{FF2B5EF4-FFF2-40B4-BE49-F238E27FC236}">
+                <a16:creationId xmlns:a16="http://schemas.microsoft.com/office/drawing/2014/main" id="{DB74D2FB-12C7-57AA-FADD-8E8C969423A8}"/>
+              </a:ext>
+            </a:extLst>
+          </p:cNvPr>
+          <p:cNvSpPr>
+            <a:spLocks noGrp="1"/>
+          </p:cNvSpPr>
+          <p:nvPr>
+            <p:ph type="title"/>
+          </p:nvPr>
+        </p:nvSpPr>
+        <p:spPr/>
+        <p:txBody>
+          <a:bodyPr/>
+          <a:lstStyle/>
+          <a:p>
+            <a:r>
+              <a:rPr lang="de-DE" dirty="0" err="1"/>
+              <a:t>Direct</a:t>
+            </a:r>
+            <a:r>
+              <a:rPr lang="de-DE" dirty="0"/>
+              <a:t> </a:t>
+            </a:r>
+            <a:r>
+              <a:rPr lang="de-DE" dirty="0" err="1"/>
+              <a:t>Current</a:t>
+            </a:r>
+            <a:r>
+              <a:rPr lang="de-DE" dirty="0"/>
+              <a:t> </a:t>
+            </a:r>
+            <a:r>
+              <a:rPr lang="de-DE" dirty="0" err="1"/>
+              <a:t>Circuits</a:t>
+            </a:r>
+            <a:endParaRPr lang="de-DE" dirty="0"/>
+          </a:p>
+        </p:txBody>
+      </p:sp>
+      <p:sp>
+        <p:nvSpPr>
+          <p:cNvPr id="3" name="Inhaltsplatzhalter 2">
+            <a:extLst>
+              <a:ext uri="{FF2B5EF4-FFF2-40B4-BE49-F238E27FC236}">
+                <a16:creationId xmlns:a16="http://schemas.microsoft.com/office/drawing/2014/main" id="{96CB17E7-EF89-1307-64B3-BBA6BC800C6E}"/>
+              </a:ext>
+            </a:extLst>
+          </p:cNvPr>
+          <p:cNvSpPr>
+            <a:spLocks noGrp="1"/>
+          </p:cNvSpPr>
+          <p:nvPr>
+            <p:ph idx="1"/>
+          </p:nvPr>
+        </p:nvSpPr>
+        <p:spPr/>
+        <p:txBody>
+          <a:bodyPr>
+            <a:normAutofit lnSpcReduction="10000"/>
+          </a:bodyPr>
+          <a:lstStyle/>
+          <a:p>
+            <a:r>
+              <a:rPr lang="de-DE" dirty="0"/>
+              <a:t>Reference </a:t>
+            </a:r>
+            <a:r>
+              <a:rPr lang="de-DE" dirty="0" err="1"/>
+              <a:t>Directions</a:t>
+            </a:r>
+            <a:endParaRPr lang="de-DE" dirty="0"/>
+          </a:p>
+          <a:p>
+            <a:r>
+              <a:rPr lang="de-DE" dirty="0" err="1"/>
+              <a:t>Kirchhoff‘s</a:t>
+            </a:r>
+            <a:r>
+              <a:rPr lang="de-DE" dirty="0"/>
+              <a:t> </a:t>
+            </a:r>
+            <a:r>
+              <a:rPr lang="de-DE" dirty="0" err="1"/>
+              <a:t>Current</a:t>
+            </a:r>
+            <a:r>
+              <a:rPr lang="de-DE" dirty="0"/>
+              <a:t> Law</a:t>
+            </a:r>
+          </a:p>
+          <a:p>
+            <a:r>
+              <a:rPr lang="de-DE" dirty="0" err="1"/>
+              <a:t>Kirchhoff‘s</a:t>
+            </a:r>
+            <a:r>
+              <a:rPr lang="de-DE" dirty="0"/>
+              <a:t> </a:t>
+            </a:r>
+            <a:r>
+              <a:rPr lang="de-DE" dirty="0" err="1"/>
+              <a:t>Voltage</a:t>
+            </a:r>
+            <a:r>
+              <a:rPr lang="de-DE" dirty="0"/>
+              <a:t> Law</a:t>
+            </a:r>
+          </a:p>
+          <a:p>
+            <a:r>
+              <a:rPr lang="de-DE" dirty="0"/>
+              <a:t>Series Circuit</a:t>
+            </a:r>
+          </a:p>
+          <a:p>
+            <a:r>
+              <a:rPr lang="de-DE" dirty="0"/>
+              <a:t>Parallel Circuit</a:t>
+            </a:r>
+          </a:p>
+          <a:p>
+            <a:r>
+              <a:rPr lang="de-DE" dirty="0" err="1"/>
+              <a:t>Practical</a:t>
+            </a:r>
+            <a:r>
+              <a:rPr lang="de-DE" dirty="0"/>
+              <a:t> </a:t>
+            </a:r>
+            <a:r>
+              <a:rPr lang="de-DE" dirty="0" err="1"/>
+              <a:t>Voltage</a:t>
+            </a:r>
+            <a:r>
+              <a:rPr lang="de-DE" dirty="0"/>
+              <a:t> &amp; </a:t>
+            </a:r>
+            <a:r>
+              <a:rPr lang="de-DE" dirty="0" err="1"/>
+              <a:t>Current</a:t>
+            </a:r>
+            <a:r>
+              <a:rPr lang="de-DE" dirty="0"/>
+              <a:t> Sources</a:t>
+            </a:r>
+          </a:p>
+          <a:p>
+            <a:r>
+              <a:rPr lang="de-DE" dirty="0"/>
+              <a:t>Network Analysis</a:t>
+            </a:r>
+          </a:p>
+          <a:p>
+            <a:r>
+              <a:rPr lang="de-DE" dirty="0"/>
+              <a:t>Efficiency &amp; Power/</a:t>
+            </a:r>
+            <a:r>
+              <a:rPr lang="de-DE" dirty="0" err="1"/>
+              <a:t>Impedance</a:t>
+            </a:r>
+            <a:r>
+              <a:rPr lang="de-DE" dirty="0"/>
+              <a:t> </a:t>
+            </a:r>
+            <a:r>
+              <a:rPr lang="de-DE" dirty="0" err="1"/>
+              <a:t>Matching</a:t>
+            </a:r>
+            <a:endParaRPr lang="de-DE" dirty="0"/>
+          </a:p>
+          <a:p>
+            <a:r>
+              <a:rPr lang="de-DE" dirty="0" err="1"/>
+              <a:t>Voltage</a:t>
+            </a:r>
+            <a:r>
+              <a:rPr lang="de-DE" dirty="0"/>
+              <a:t> &amp; </a:t>
+            </a:r>
+            <a:r>
+              <a:rPr lang="de-DE" dirty="0" err="1"/>
+              <a:t>Current</a:t>
+            </a:r>
+            <a:r>
+              <a:rPr lang="de-DE" dirty="0"/>
+              <a:t> Measurement</a:t>
+            </a:r>
+          </a:p>
+        </p:txBody>
+      </p:sp>
+      <p:sp>
+        <p:nvSpPr>
+          <p:cNvPr id="4" name="Foliennummernplatzhalter 3">
+            <a:extLst>
+              <a:ext uri="{FF2B5EF4-FFF2-40B4-BE49-F238E27FC236}">
+                <a16:creationId xmlns:a16="http://schemas.microsoft.com/office/drawing/2014/main" id="{7F88B751-5AB7-71F9-9B7D-4A3F44B12F73}"/>
+              </a:ext>
+            </a:extLst>
+          </p:cNvPr>
+          <p:cNvSpPr>
+            <a:spLocks noGrp="1"/>
+          </p:cNvSpPr>
+          <p:nvPr>
+            <p:ph type="sldNum" sz="quarter" idx="12"/>
+          </p:nvPr>
+        </p:nvSpPr>
+        <p:spPr/>
+        <p:txBody>
+          <a:bodyPr/>
+          <a:lstStyle/>
+          <a:p>
+            <a:fld id="{BA3EAA6B-85FB-CD46-8BDC-C1BC3364C8C0}" type="slidenum">
+              <a:rPr lang="de-DE" smtClean="0"/>
+              <a:t>3</a:t>
+            </a:fld>
+            <a:endParaRPr lang="de-DE"/>
+          </a:p>
+        </p:txBody>
+      </p:sp>
+    </p:spTree>
+    <p:extLst>
+      <p:ext uri="{BB962C8B-B14F-4D97-AF65-F5344CB8AC3E}">
+        <p14:creationId xmlns:p14="http://schemas.microsoft.com/office/powerpoint/2010/main" val="4147866485"/>
+      </p:ext>
+    </p:extLst>
+  </p:cSld>
+  <p:clrMapOvr>
+    <a:masterClrMapping/>
+  </p:clrMapOvr>
+</p:sld>
+</file>
+
+<file path=ppt/slides/slide30.xml><?xml version="1.0" encoding="utf-8"?>
 <p:sld xmlns:a="http://schemas.openxmlformats.org/drawingml/2006/main" xmlns:r="http://schemas.openxmlformats.org/officeDocument/2006/relationships" xmlns:p="http://schemas.openxmlformats.org/presentationml/2006/main">
   <p:cSld>
     <p:spTree>
@@ -23087,7 +24933,7 @@
           <a:p>
             <a:fld id="{BA3EAA6B-85FB-CD46-8BDC-C1BC3364C8C0}" type="slidenum">
               <a:rPr lang="de-DE" smtClean="0"/>
-              <a:t>29</a:t>
+              <a:t>30</a:t>
             </a:fld>
             <a:endParaRPr lang="de-DE"/>
           </a:p>
@@ -23598,263 +25444,7 @@
 </p:sld>
 </file>
 
-<file path=ppt/slides/slide3.xml><?xml version="1.0" encoding="utf-8"?>
-<p:sld xmlns:a="http://schemas.openxmlformats.org/drawingml/2006/main" xmlns:r="http://schemas.openxmlformats.org/officeDocument/2006/relationships" xmlns:p="http://schemas.openxmlformats.org/presentationml/2006/main">
-  <p:cSld>
-    <p:spTree>
-      <p:nvGrpSpPr>
-        <p:cNvPr id="1" name=""/>
-        <p:cNvGrpSpPr/>
-        <p:nvPr/>
-      </p:nvGrpSpPr>
-      <p:grpSpPr>
-        <a:xfrm>
-          <a:off x="0" y="0"/>
-          <a:ext cx="0" cy="0"/>
-          <a:chOff x="0" y="0"/>
-          <a:chExt cx="0" cy="0"/>
-        </a:xfrm>
-      </p:grpSpPr>
-      <p:sp>
-        <p:nvSpPr>
-          <p:cNvPr id="2" name="Titel 1">
-            <a:extLst>
-              <a:ext uri="{FF2B5EF4-FFF2-40B4-BE49-F238E27FC236}">
-                <a16:creationId xmlns:a16="http://schemas.microsoft.com/office/drawing/2014/main" id="{DB74D2FB-12C7-57AA-FADD-8E8C969423A8}"/>
-              </a:ext>
-            </a:extLst>
-          </p:cNvPr>
-          <p:cNvSpPr>
-            <a:spLocks noGrp="1"/>
-          </p:cNvSpPr>
-          <p:nvPr>
-            <p:ph type="title"/>
-          </p:nvPr>
-        </p:nvSpPr>
-        <p:spPr/>
-        <p:txBody>
-          <a:bodyPr/>
-          <a:lstStyle/>
-          <a:p>
-            <a:r>
-              <a:rPr lang="de-DE" dirty="0" err="1"/>
-              <a:t>Direct</a:t>
-            </a:r>
-            <a:r>
-              <a:rPr lang="de-DE" dirty="0"/>
-              <a:t> </a:t>
-            </a:r>
-            <a:r>
-              <a:rPr lang="de-DE" dirty="0" err="1"/>
-              <a:t>Current</a:t>
-            </a:r>
-            <a:r>
-              <a:rPr lang="de-DE" dirty="0"/>
-              <a:t> </a:t>
-            </a:r>
-            <a:r>
-              <a:rPr lang="de-DE" dirty="0" err="1"/>
-              <a:t>Circuits</a:t>
-            </a:r>
-            <a:endParaRPr lang="de-DE" dirty="0"/>
-          </a:p>
-        </p:txBody>
-      </p:sp>
-      <p:sp>
-        <p:nvSpPr>
-          <p:cNvPr id="3" name="Inhaltsplatzhalter 2">
-            <a:extLst>
-              <a:ext uri="{FF2B5EF4-FFF2-40B4-BE49-F238E27FC236}">
-                <a16:creationId xmlns:a16="http://schemas.microsoft.com/office/drawing/2014/main" id="{96CB17E7-EF89-1307-64B3-BBA6BC800C6E}"/>
-              </a:ext>
-            </a:extLst>
-          </p:cNvPr>
-          <p:cNvSpPr>
-            <a:spLocks noGrp="1"/>
-          </p:cNvSpPr>
-          <p:nvPr>
-            <p:ph idx="1"/>
-          </p:nvPr>
-        </p:nvSpPr>
-        <p:spPr/>
-        <p:txBody>
-          <a:bodyPr>
-            <a:normAutofit lnSpcReduction="10000"/>
-          </a:bodyPr>
-          <a:lstStyle/>
-          <a:p>
-            <a:r>
-              <a:rPr lang="de-DE" dirty="0"/>
-              <a:t>Reference </a:t>
-            </a:r>
-            <a:r>
-              <a:rPr lang="de-DE" dirty="0" err="1"/>
-              <a:t>Directions</a:t>
-            </a:r>
-            <a:endParaRPr lang="de-DE" dirty="0"/>
-          </a:p>
-          <a:p>
-            <a:r>
-              <a:rPr lang="de-DE" dirty="0" err="1"/>
-              <a:t>Kirchhoff‘s</a:t>
-            </a:r>
-            <a:r>
-              <a:rPr lang="de-DE" dirty="0"/>
-              <a:t> </a:t>
-            </a:r>
-            <a:r>
-              <a:rPr lang="de-DE" dirty="0" err="1"/>
-              <a:t>Current</a:t>
-            </a:r>
-            <a:r>
-              <a:rPr lang="de-DE" dirty="0"/>
-              <a:t> Law</a:t>
-            </a:r>
-          </a:p>
-          <a:p>
-            <a:r>
-              <a:rPr lang="de-DE" dirty="0" err="1"/>
-              <a:t>Kirchhoff‘s</a:t>
-            </a:r>
-            <a:r>
-              <a:rPr lang="de-DE" dirty="0"/>
-              <a:t> </a:t>
-            </a:r>
-            <a:r>
-              <a:rPr lang="de-DE" dirty="0" err="1"/>
-              <a:t>Voltage</a:t>
-            </a:r>
-            <a:r>
-              <a:rPr lang="de-DE" dirty="0"/>
-              <a:t> Law</a:t>
-            </a:r>
-          </a:p>
-          <a:p>
-            <a:r>
-              <a:rPr lang="de-DE" dirty="0"/>
-              <a:t>Series Circuit</a:t>
-            </a:r>
-          </a:p>
-          <a:p>
-            <a:r>
-              <a:rPr lang="de-DE" dirty="0"/>
-              <a:t>Parallel Circuit</a:t>
-            </a:r>
-          </a:p>
-          <a:p>
-            <a:r>
-              <a:rPr lang="de-DE" dirty="0" err="1"/>
-              <a:t>Practical</a:t>
-            </a:r>
-            <a:r>
-              <a:rPr lang="de-DE" dirty="0"/>
-              <a:t> </a:t>
-            </a:r>
-            <a:r>
-              <a:rPr lang="de-DE" dirty="0" err="1"/>
-              <a:t>Voltage</a:t>
-            </a:r>
-            <a:r>
-              <a:rPr lang="de-DE" dirty="0"/>
-              <a:t> &amp; </a:t>
-            </a:r>
-            <a:r>
-              <a:rPr lang="de-DE" dirty="0" err="1"/>
-              <a:t>Current</a:t>
-            </a:r>
-            <a:r>
-              <a:rPr lang="de-DE" dirty="0"/>
-              <a:t> Sources</a:t>
-            </a:r>
-          </a:p>
-          <a:p>
-            <a:r>
-              <a:rPr lang="de-DE" dirty="0"/>
-              <a:t>Network Analysis</a:t>
-            </a:r>
-          </a:p>
-          <a:p>
-            <a:r>
-              <a:rPr lang="de-DE" dirty="0"/>
-              <a:t>Efficiency &amp; Power/</a:t>
-            </a:r>
-            <a:r>
-              <a:rPr lang="de-DE" dirty="0" err="1"/>
-              <a:t>Impedance</a:t>
-            </a:r>
-            <a:r>
-              <a:rPr lang="de-DE" dirty="0"/>
-              <a:t> </a:t>
-            </a:r>
-            <a:r>
-              <a:rPr lang="de-DE" dirty="0" err="1"/>
-              <a:t>Matching</a:t>
-            </a:r>
-            <a:endParaRPr lang="de-DE" dirty="0"/>
-          </a:p>
-          <a:p>
-            <a:r>
-              <a:rPr lang="de-DE" dirty="0" err="1"/>
-              <a:t>Voltage</a:t>
-            </a:r>
-            <a:r>
-              <a:rPr lang="de-DE" dirty="0"/>
-              <a:t> &amp; </a:t>
-            </a:r>
-            <a:r>
-              <a:rPr lang="de-DE" dirty="0" err="1"/>
-              <a:t>Current</a:t>
-            </a:r>
-            <a:r>
-              <a:rPr lang="de-DE" dirty="0"/>
-              <a:t> Measurement</a:t>
-            </a:r>
-          </a:p>
-        </p:txBody>
-      </p:sp>
-      <p:sp>
-        <p:nvSpPr>
-          <p:cNvPr id="4" name="Foliennummernplatzhalter 3">
-            <a:extLst>
-              <a:ext uri="{FF2B5EF4-FFF2-40B4-BE49-F238E27FC236}">
-                <a16:creationId xmlns:a16="http://schemas.microsoft.com/office/drawing/2014/main" id="{7F88B751-5AB7-71F9-9B7D-4A3F44B12F73}"/>
-              </a:ext>
-            </a:extLst>
-          </p:cNvPr>
-          <p:cNvSpPr>
-            <a:spLocks noGrp="1"/>
-          </p:cNvSpPr>
-          <p:nvPr>
-            <p:ph type="sldNum" sz="quarter" idx="12"/>
-          </p:nvPr>
-        </p:nvSpPr>
-        <p:spPr/>
-        <p:txBody>
-          <a:bodyPr/>
-          <a:lstStyle/>
-          <a:p>
-            <a:fld id="{BA3EAA6B-85FB-CD46-8BDC-C1BC3364C8C0}" type="slidenum">
-              <a:rPr lang="de-DE" smtClean="0"/>
-              <a:t>3</a:t>
-            </a:fld>
-            <a:endParaRPr lang="de-DE"/>
-          </a:p>
-        </p:txBody>
-      </p:sp>
-    </p:spTree>
-    <p:extLst>
-      <p:ext uri="{BB962C8B-B14F-4D97-AF65-F5344CB8AC3E}">
-        <p14:creationId xmlns:p14="http://schemas.microsoft.com/office/powerpoint/2010/main" val="4147866485"/>
-      </p:ext>
-    </p:extLst>
-  </p:cSld>
-  <p:clrMapOvr>
-    <a:masterClrMapping/>
-  </p:clrMapOvr>
-</p:sld>
-</file>
-
-<file path=ppt/slides/slide30.xml><?xml version="1.0" encoding="utf-8"?>
+<file path=ppt/slides/slide31.xml><?xml version="1.0" encoding="utf-8"?>
 <p:sld xmlns:a="http://schemas.openxmlformats.org/drawingml/2006/main" xmlns:r="http://schemas.openxmlformats.org/officeDocument/2006/relationships" xmlns:p="http://schemas.openxmlformats.org/presentationml/2006/main">
   <p:cSld>
     <p:spTree>
@@ -23934,7 +25524,7 @@
           <a:p>
             <a:fld id="{BA3EAA6B-85FB-CD46-8BDC-C1BC3364C8C0}" type="slidenum">
               <a:rPr lang="de-DE" smtClean="0"/>
-              <a:t>30</a:t>
+              <a:t>31</a:t>
             </a:fld>
             <a:endParaRPr lang="de-DE"/>
           </a:p>
@@ -24467,7 +26057,7 @@
 </p:sld>
 </file>
 
-<file path=ppt/slides/slide31.xml><?xml version="1.0" encoding="utf-8"?>
+<file path=ppt/slides/slide32.xml><?xml version="1.0" encoding="utf-8"?>
 <p:sld xmlns:a="http://schemas.openxmlformats.org/drawingml/2006/main" xmlns:r="http://schemas.openxmlformats.org/officeDocument/2006/relationships" xmlns:p="http://schemas.openxmlformats.org/presentationml/2006/main">
   <p:cSld>
     <p:spTree>
@@ -24635,7 +26225,7 @@
           <a:p>
             <a:fld id="{BA3EAA6B-85FB-CD46-8BDC-C1BC3364C8C0}" type="slidenum">
               <a:rPr lang="de-DE" smtClean="0"/>
-              <a:t>31</a:t>
+              <a:t>32</a:t>
             </a:fld>
             <a:endParaRPr lang="de-DE"/>
           </a:p>

</xml_diff>